<commit_message>
Reframe target users as students studying on campus with 15-minute breaks between periods; drop dormitory premise
</commit_message>
<xml_diff>
--- a/07-trinh-bay/BreakBite_Lab2_Presentation.pptx
+++ b/07-trinh-bay/BreakBite_Lab2_Presentation.pptx
@@ -3524,7 +3524,7 @@
                 </a:solidFill>
                 <a:latin typeface="Calibri"/>
               </a:rPr>
-              <a:t>Ăn kịp trong 15 phút giữa hai slot, không phải xếp hàng.</a:t>
+              <a:t>Ăn kịp trong 15 phút giữa hai tiết, không phải xếp hàng.</a:t>
             </a:r>
           </a:p>
         </p:txBody>
@@ -34231,7 +34231,7 @@
                 </a:solidFill>
                 <a:latin typeface="Calibri"/>
               </a:rPr>
-              <a:t>Sinh viên ở ký túc xá có lịch học dày thường không mua kịp đồ ăn trong giờ nghỉ ngắn giữa hai slot, khi hàng chờ ở căn tin dồn đúng giờ nghỉ chung, nên họ bỏ bữa hoặc vào lớp trễ.</a:t>
+              <a:t>Sinh viên học trên campus có lịch học dày thường không mua kịp đồ ăn trong 15 phút nghỉ giữa hai tiết, vì xếp hàng ở căn tin dồn đúng giờ nghỉ chung và tốn gần hết thời gian, nên họ bỏ bữa hoặc vào lớp trễ.</a:t>
             </a:r>
           </a:p>
           <a:p>
@@ -34374,7 +34374,7 @@
                 </a:solidFill>
                 <a:latin typeface="Calibri"/>
               </a:rPr>
-              <a:t>Bỏ bữa hoặc vào lớp trễ</a:t>
+              <a:t>Xếp hàng gần hết 15 phút nghỉ, bỏ bữa hoặc vào lớp trễ</a:t>
             </a:r>
           </a:p>
         </p:txBody>
@@ -41248,7 +41248,7 @@
                           </a:solidFill>
                           <a:latin typeface="Calibri"/>
                         </a:rPr>
-                        <a:t>Giờ nghỉ giữa hai slot ≤ 15 phút</a:t>
+                        <a:t>Giờ nghỉ giữa hai tiết ≤ 15 phút</a:t>
                       </a:r>
                     </a:p>
                   </a:txBody>
@@ -42508,7 +42508,7 @@
                 </a:solidFill>
                 <a:latin typeface="Calibri"/>
               </a:rPr>
-              <a:t>RQ1 · Giữa hai slot thật sự có bao nhiêu phút?</a:t>
+              <a:t>RQ1 · Giữa hai tiết thật sự có bao nhiêu phút?</a:t>
             </a:r>
           </a:p>
         </p:txBody>
@@ -47162,7 +47162,7 @@
                 </a:solidFill>
                 <a:latin typeface="Calibri"/>
               </a:rPr>
-              <a:t>20 tuổi · SV năm 2 · ở ký túc xá</a:t>
+              <a:t>20 tuổi · SV năm 2 · học trên campus</a:t>
             </a:r>
           </a:p>
           <a:p>
@@ -47178,7 +47178,7 @@
                 </a:solidFill>
                 <a:latin typeface="Calibri"/>
               </a:rPr>
-              <a:t>3 slot mỗi ngày, nghỉ khoảng 15 phút</a:t>
+              <a:t>Học nhiều tiết liền, nghỉ 15 phút giữa hai tiết</a:t>
             </a:r>
           </a:p>
           <a:p>
@@ -47483,7 +47483,7 @@
                 </a:solidFill>
                 <a:latin typeface="Calibri"/>
               </a:rPr>
-              <a:t>19 tuổi · SV năm 1 Thiết kế · ở trọ</a:t>
+              <a:t>19 tuổi · SV năm 1 Thiết kế · đi xe buýt</a:t>
             </a:r>
           </a:p>
           <a:p>

</xml_diff>

<commit_message>
Keep 'slot' wording for class periods; only the dormitory premise stays removed
</commit_message>
<xml_diff>
--- a/07-trinh-bay/BreakBite_Lab2_Presentation.pptx
+++ b/07-trinh-bay/BreakBite_Lab2_Presentation.pptx
@@ -3524,7 +3524,7 @@
                 </a:solidFill>
                 <a:latin typeface="Calibri"/>
               </a:rPr>
-              <a:t>Ăn kịp trong 15 phút giữa hai tiết, không phải xếp hàng.</a:t>
+              <a:t>Ăn kịp trong 15 phút giữa hai slot, không phải xếp hàng.</a:t>
             </a:r>
           </a:p>
         </p:txBody>
@@ -34231,7 +34231,7 @@
                 </a:solidFill>
                 <a:latin typeface="Calibri"/>
               </a:rPr>
-              <a:t>Sinh viên học trên campus có lịch học dày thường không mua kịp đồ ăn trong 15 phút nghỉ giữa hai tiết, vì xếp hàng ở căn tin dồn đúng giờ nghỉ chung và tốn gần hết thời gian, nên họ bỏ bữa hoặc vào lớp trễ.</a:t>
+              <a:t>Sinh viên học trên campus có lịch học dày thường không mua kịp đồ ăn trong 15 phút nghỉ giữa hai slot, vì xếp hàng ở căn tin dồn đúng giờ nghỉ chung và tốn gần hết thời gian, nên họ bỏ bữa hoặc vào lớp trễ.</a:t>
             </a:r>
           </a:p>
           <a:p>
@@ -41248,7 +41248,7 @@
                           </a:solidFill>
                           <a:latin typeface="Calibri"/>
                         </a:rPr>
-                        <a:t>Giờ nghỉ giữa hai tiết ≤ 15 phút</a:t>
+                        <a:t>Giờ nghỉ giữa hai slot ≤ 15 phút</a:t>
                       </a:r>
                     </a:p>
                   </a:txBody>
@@ -42508,7 +42508,7 @@
                 </a:solidFill>
                 <a:latin typeface="Calibri"/>
               </a:rPr>
-              <a:t>RQ1 · Giữa hai tiết thật sự có bao nhiêu phút?</a:t>
+              <a:t>RQ1 · Giữa hai slot thật sự có bao nhiêu phút?</a:t>
             </a:r>
           </a:p>
         </p:txBody>
@@ -47178,7 +47178,7 @@
                 </a:solidFill>
                 <a:latin typeface="Calibri"/>
               </a:rPr>
-              <a:t>Học nhiều tiết liền, nghỉ 15 phút giữa hai tiết</a:t>
+              <a:t>Học nhiều slot liền, nghỉ 15 phút giữa hai slot</a:t>
             </a:r>
           </a:p>
           <a:p>

</xml_diff>

<commit_message>
Final deck: fix concept slide layout, update closing slide, add PDF copy
</commit_message>
<xml_diff>
--- a/07-trinh-bay/BreakBite_Lab2_Presentation.pptx
+++ b/07-trinh-bay/BreakBite_Lab2_Presentation.pptx
@@ -12199,8 +12199,8 @@
         </p:blipFill>
         <p:spPr>
           <a:xfrm>
-            <a:off x="548640" y="1463040"/>
-            <a:ext cx="7040880" cy="5339334"/>
+            <a:off x="1463040" y="1463040"/>
+            <a:ext cx="5124659" cy="3886200"/>
           </a:xfrm>
           <a:prstGeom prst="rect">
             <a:avLst/>
@@ -39447,7 +39447,7 @@
                 </a:solidFill>
                 <a:latin typeface="Calibri"/>
               </a:rPr>
-              <a:t>Chạy Present trên prototype v2</a:t>
+              <a:t>Chạy Present trên prototype (Page 06)</a:t>
             </a:r>
           </a:p>
         </p:txBody>

</xml_diff>

<commit_message>
Rework order prototype flow: quick-add snackbar, payment method variants, payment gateway, Back by history; update tests, docs and deck text
</commit_message>
<xml_diff>
--- a/07-trinh-bay/BreakBite_Lab2_Presentation.pptx
+++ b/07-trinh-bay/BreakBite_Lab2_Presentation.pptx
@@ -18535,7 +18535,7 @@
                           </a:solidFill>
                           <a:latin typeface="Calibri"/>
                         </a:rPr>
-                        <a:t>0 / 217</a:t>
+                        <a:t>0 / 262</a:t>
                       </a:r>
                     </a:p>
                   </a:txBody>
@@ -30266,45 +30266,6 @@
           </a:p>
         </p:txBody>
       </p:sp>
-      <p:sp>
-        <p:nvSpPr>
-          <p:cNvPr id="71" name="TextBox 70"/>
-          <p:cNvSpPr txBox="1"/>
-          <p:nvPr/>
-        </p:nvSpPr>
-        <p:spPr>
-          <a:xfrm>
-            <a:off x="777240" y="5943600"/>
-            <a:ext cx="10652760" cy="347472"/>
-          </a:xfrm>
-          <a:prstGeom prst="rect">
-            <a:avLst/>
-          </a:prstGeom>
-          <a:noFill/>
-        </p:spPr>
-        <p:txBody>
-          <a:bodyPr wrap="square" lIns="0" tIns="0" rIns="0" bIns="0" anchor="ctr">
-            <a:spAutoFit/>
-          </a:bodyPr>
-          <a:lstStyle/>
-          <a:p>
-            <a:pPr algn="l">
-              <a:spcAft>
-                <a:spcPts val="300"/>
-              </a:spcAft>
-            </a:pPr>
-            <a:r>
-              <a:rPr sz="1100" b="0">
-                <a:solidFill>
-                  <a:srgbClr val="622B14"/>
-                </a:solidFill>
-                <a:latin typeface="Calibri"/>
-              </a:rPr>
-              <a:t>Nguồn pain point: 03-P2-ux-design/01-persona.md và 02-P1-nghien-cuu/02-research.md; dữ liệu persona là giả định, chờ khảo sát thật.</a:t>
-            </a:r>
-          </a:p>
-        </p:txBody>
-      </p:sp>
     </p:spTree>
   </p:cSld>
   <p:clrMapOvr>
@@ -31032,7 +30993,7 @@
                 </a:solidFill>
                 <a:latin typeface="Calibri"/>
               </a:rPr>
-              <a:t>58 màn v2, bản 360 và 412 dp</a:t>
+              <a:t>64 màn v2, bản 360 và 412 dp</a:t>
             </a:r>
           </a:p>
         </p:txBody>
@@ -31416,7 +31377,7 @@
                 </a:solidFill>
                 <a:latin typeface="Calibri"/>
               </a:rPr>
-              <a:t>58 màn nối liên kết, 17 điểm bắt đầu để Present</a:t>
+              <a:t>64 màn nối liên kết, 19 điểm bắt đầu để Present</a:t>
             </a:r>
           </a:p>
         </p:txBody>
@@ -32819,7 +32780,7 @@
                 </a:solidFill>
                 <a:latin typeface="Calibri"/>
               </a:rPr>
-              <a:t>220 liên kết trên 58 khung, 17 điểm bắt đầu</a:t>
+              <a:t>Hơn 260 vùng bấm trên 64 khung, 19 điểm bắt đầu</a:t>
             </a:r>
           </a:p>
           <a:p>
@@ -32851,7 +32812,7 @@
                 </a:solidFill>
                 <a:latin typeface="Calibri"/>
               </a:rPr>
-              <a:t>Màn đang tải tự chuyển sau 1,2 giây</a:t>
+              <a:t>Thêm vào giỏ, chọn phương thức, cổng thanh toán thành công hoặc bị từ chối</a:t>
             </a:r>
           </a:p>
           <a:p>
@@ -33121,7 +33082,7 @@
                 </a:solidFill>
                 <a:latin typeface="Calibri"/>
               </a:rPr>
-              <a:t>Demo: bấm combo → thêm vào giỏ → thanh toán → đang tải → mã nhận #A-204; rồi mở app người bán nhận đơn đó.</a:t>
+              <a:t>Demo: chạm + → Xem giỏ → Tiếp tục thanh toán → chọn phương thức → xác nhận → cổng thanh toán → mã nhận #A-204; rồi mở app người bán nhận đơn đó.</a:t>
             </a:r>
           </a:p>
         </p:txBody>
@@ -33837,7 +33798,7 @@
                 </a:solidFill>
                 <a:latin typeface="Calibri"/>
               </a:rPr>
-              <a:t>0 / 217 vùng dưới 48 dp</a:t>
+              <a:t>0 / 262 vùng dưới 48 dp</a:t>
             </a:r>
           </a:p>
         </p:txBody>
@@ -36057,7 +36018,7 @@
                 </a:solidFill>
                 <a:latin typeface="Calibri"/>
               </a:rPr>
-              <a:t>Đồ thị flow bản v2: 7 / 7 test đạt</a:t>
+              <a:t>Đồ thị flow bản v2: 10 / 10 test đạt</a:t>
             </a:r>
           </a:p>
           <a:p>
@@ -36073,7 +36034,7 @@
                 </a:solidFill>
                 <a:latin typeface="Calibri"/>
               </a:rPr>
-              <a:t>Đặt đơn từ Trang chủ tới Theo dõi đơn: 3 chạm</a:t>
+              <a:t>Đặt đơn từ Trang chủ tới Theo dõi đơn: 5 chạm, qua giỏ và cổng thanh toán</a:t>
             </a:r>
           </a:p>
           <a:p>
@@ -41195,7 +41156,7 @@
                     <a:lstStyle/>
                     <a:p>
                       <a:r>
-                        <a:rPr sz="1200" b="1">
+                        <a:rPr sz="1200" b="1" dirty="0">
                           <a:solidFill>
                             <a:srgbClr val="622B14"/>
                           </a:solidFill>
@@ -41677,14 +41638,56 @@
                     <a:lstStyle/>
                     <a:p>
                       <a:r>
-                        <a:rPr sz="1200" b="0">
+                        <a:rPr sz="1200" b="0" dirty="0" err="1">
                           <a:solidFill>
                             <a:srgbClr val="622B14"/>
                           </a:solidFill>
                           <a:latin typeface="Calibri"/>
                         </a:rPr>
-                        <a:t>Hỏi chủ quán</a:t>
+                        <a:t>Hỏi</a:t>
                       </a:r>
+                      <a:r>
+                        <a:rPr sz="1200" b="0" dirty="0">
+                          <a:solidFill>
+                            <a:srgbClr val="622B14"/>
+                          </a:solidFill>
+                          <a:latin typeface="Calibri"/>
+                        </a:rPr>
+                        <a:t> </a:t>
+                      </a:r>
+                      <a:r>
+                        <a:rPr sz="1200" b="0" dirty="0" err="1">
+                          <a:solidFill>
+                            <a:srgbClr val="622B14"/>
+                          </a:solidFill>
+                          <a:latin typeface="Calibri"/>
+                        </a:rPr>
+                        <a:t>chủ</a:t>
+                      </a:r>
+                      <a:r>
+                        <a:rPr sz="1200" b="0" dirty="0">
+                          <a:solidFill>
+                            <a:srgbClr val="622B14"/>
+                          </a:solidFill>
+                          <a:latin typeface="Calibri"/>
+                        </a:rPr>
+                        <a:t> </a:t>
+                      </a:r>
+                      <a:r>
+                        <a:rPr sz="1200" b="0" dirty="0" err="1">
+                          <a:solidFill>
+                            <a:srgbClr val="622B14"/>
+                          </a:solidFill>
+                          <a:latin typeface="Calibri"/>
+                        </a:rPr>
+                        <a:t>quán</a:t>
+                      </a:r>
+                      <a:endParaRPr sz="1200" b="0" dirty="0">
+                        <a:solidFill>
+                          <a:srgbClr val="622B14"/>
+                        </a:solidFill>
+                        <a:latin typeface="Calibri"/>
+                      </a:endParaRPr>
                     </a:p>
                   </a:txBody>
                   <a:tcPr anchor="ctr">
@@ -44313,7 +44316,7 @@
         <p:spPr>
           <a:xfrm>
             <a:off x="548640" y="3383280"/>
-            <a:ext cx="11064240" cy="274320"/>
+            <a:ext cx="11064240" cy="169277"/>
           </a:xfrm>
           <a:prstGeom prst="rect">
             <a:avLst/>
@@ -44332,13 +44335,13 @@
               </a:spcAft>
             </a:pPr>
             <a:r>
-              <a:rPr sz="1100" b="1">
+              <a:rPr sz="1100" b="1" dirty="0">
                 <a:solidFill>
                   <a:srgbClr val="6B5F55"/>
                 </a:solidFill>
                 <a:latin typeface="Calibri"/>
               </a:rPr>
-              <a:t>KHẢO SÁT GOOGLE FORM · CHẠY THỬ 20 PHẢN HỒI MÔ PHỎNG (SIM-S01…S20)</a:t>
+              <a:t>KHẢO SÁT GOOGLE FORM · 20 PHẢN HỒI  </a:t>
             </a:r>
           </a:p>
         </p:txBody>

</xml_diff>